<commit_message>
docs(ppt): rebrand EvidenceLoop->EvidenceRing, fix demo port, add delivered-capability slide
- brand: all footers + comparison table header renamed (EvidenceRing)
- demo URL footer: localhost:4173 -> 5280 (4173 EACCES on this machine)
- page footers N/10 -> N/11
- new slide 11 '已交付能力（2026-08-14）': core loop / engineering
  delivery / finals 加码 / honest boundary columns (paper submit, parent
  view + child binding, Excel CSV, Docker sandbox, 7-题型 9-学科, etc.)
- slide cloned from roadmap layout; XML-validated, 11 slides registered
</commit_message>
<xml_diff>
--- a/docs/EvidenceRing-初赛路演.pptx
+++ b/docs/EvidenceRing-初赛路演.pptx
@@ -18,6 +18,7 @@
     <p:sldId id="263" r:id="rId11"/>
     <p:sldId id="264" r:id="rId12"/>
     <p:sldId id="265" r:id="rId13"/>
+    <p:sldId id="266" r:id="rId17"/>
   </p:sldIdLst>
   <p:sldSz cx="12191365" cy="6858000"/>
   <p:notesSz cx="6858000" cy="12191365"/>
@@ -3074,7 +3075,7 @@
                 <a:ea typeface="Consolas" panose="020B0609020204030204" pitchFamily="34" charset="-122"/>
                 <a:cs typeface="Consolas" panose="020B0609020204030204" pitchFamily="34" charset="-120"/>
               </a:rPr>
-              <a:t>本地演示：cd D:\code_space\evidence-loop  →  npm run dev  →  http://localhost:4173</a:t>
+              <a:t>本地演示：cd D:\code_space\evidence-loop  →  npm run dev  →  http://localhost:5280</a:t>
             </a:r>
             <a:endParaRPr lang="en-US" sz="1300" dirty="0"/>
           </a:p>
@@ -3112,7 +3113,7 @@
                 <a:ea typeface="微软雅黑" panose="020B0503020204020204" pitchFamily="34" charset="-122"/>
                 <a:cs typeface="微软雅黑" panose="020B0503020204020204" pitchFamily="34" charset="-120"/>
               </a:rPr>
-              <a:t>EvidenceLoop · GOAI Boundless Agents · AI+教育</a:t>
+              <a:t>EvidenceRing · GOAI Boundless Agents · AI+教育</a:t>
             </a:r>
             <a:endParaRPr lang="en-US" sz="1100" dirty="0"/>
           </a:p>
@@ -3150,7 +3151,1010 @@
                 <a:ea typeface="微软雅黑" panose="020B0503020204020204" pitchFamily="34" charset="-122"/>
                 <a:cs typeface="微软雅黑" panose="020B0503020204020204" pitchFamily="34" charset="-120"/>
               </a:rPr>
-              <a:t>10 / 10</a:t>
+              <a:t>10 / 11</a:t>
+            </a:r>
+            <a:endParaRPr lang="en-US" sz="1100" dirty="0"/>
+          </a:p>
+        </p:txBody>
+      </p:sp>
+    </p:spTree>
+  </p:cSld>
+  <p:clrMapOvr>
+    <a:masterClrMapping/>
+  </p:clrMapOvr>
+</p:sld>
+</file>
+
+<file path=ppt/slides/slide11.xml><?xml version="1.0" encoding="utf-8"?>
+<p:sld xmlns:a="http://schemas.openxmlformats.org/drawingml/2006/main" xmlns:r="http://schemas.openxmlformats.org/officeDocument/2006/relationships" xmlns:p="http://schemas.openxmlformats.org/presentationml/2006/main">
+  <p:cSld>
+    <p:spTree>
+      <p:nvGrpSpPr>
+        <p:cNvPr id="1" name=""/>
+        <p:cNvGrpSpPr/>
+        <p:nvPr/>
+      </p:nvGrpSpPr>
+      <p:grpSpPr>
+        <a:xfrm>
+          <a:off x="0" y="0"/>
+          <a:ext cx="0" cy="0"/>
+          <a:chOff x="0" y="0"/>
+          <a:chExt cx="0" cy="0"/>
+        </a:xfrm>
+      </p:grpSpPr>
+      <p:sp>
+        <p:nvSpPr>
+          <p:cNvPr id="2" name="Shape 0"/>
+          <p:cNvSpPr/>
+          <p:nvPr/>
+        </p:nvSpPr>
+        <p:spPr>
+          <a:xfrm>
+            <a:off x="0" y="0"/>
+            <a:ext cx="12191695" cy="6858000"/>
+          </a:xfrm>
+          <a:prstGeom prst="rect">
+            <a:avLst/>
+          </a:prstGeom>
+          <a:solidFill>
+            <a:srgbClr val="0B1220"/>
+          </a:solidFill>
+          <a:ln w="12700">
+            <a:solidFill>
+              <a:srgbClr val="0B1220"/>
+            </a:solidFill>
+            <a:prstDash val="solid"/>
+          </a:ln>
+        </p:spPr>
+      </p:sp>
+      <p:sp>
+        <p:nvSpPr>
+          <p:cNvPr id="3" name="Shape 1"/>
+          <p:cNvSpPr/>
+          <p:nvPr/>
+        </p:nvSpPr>
+        <p:spPr>
+          <a:xfrm>
+            <a:off x="0" y="0"/>
+            <a:ext cx="12191695" cy="73152"/>
+          </a:xfrm>
+          <a:prstGeom prst="rect">
+            <a:avLst/>
+          </a:prstGeom>
+          <a:solidFill>
+            <a:srgbClr val="22D3EE"/>
+          </a:solidFill>
+          <a:ln w="12700">
+            <a:solidFill>
+              <a:srgbClr val="22D3EE"/>
+            </a:solidFill>
+            <a:prstDash val="solid"/>
+          </a:ln>
+        </p:spPr>
+      </p:sp>
+      <p:sp>
+        <p:nvSpPr>
+          <p:cNvPr id="4" name="Text 2"/>
+          <p:cNvSpPr/>
+          <p:nvPr/>
+        </p:nvSpPr>
+        <p:spPr>
+          <a:xfrm>
+            <a:off x="502920" y="256032"/>
+            <a:ext cx="11155680" cy="502920"/>
+          </a:xfrm>
+          <a:prstGeom prst="rect">
+            <a:avLst/>
+          </a:prstGeom>
+          <a:noFill/>
+        </p:spPr>
+        <p:txBody>
+          <a:bodyPr wrap="square" rtlCol="0" anchor="ctr"/>
+          <a:lstStyle/>
+          <a:p>
+            <a:pPr marL="0" indent="0">
+              <a:buNone/>
+            </a:pPr>
+            <a:r>
+              <a:rPr lang="en-US" sz="2800" b="1" dirty="0">
+                <a:solidFill>
+                  <a:srgbClr val="F8FAFC"/>
+                </a:solidFill>
+                <a:latin typeface="微软雅黑" panose="020B0503020204020204" pitchFamily="34" charset="-122"/>
+                <a:ea typeface="微软雅黑" panose="020B0503020204020204" pitchFamily="34" charset="-122"/>
+                <a:cs typeface="微软雅黑" panose="020B0503020204020204" pitchFamily="34" charset="-120"/>
+              </a:rPr>
+              <a:t>已交付能力（2026-08-14）</a:t>
+            </a:r>
+            <a:endParaRPr lang="en-US" sz="2800" dirty="0"/>
+          </a:p>
+        </p:txBody>
+      </p:sp>
+      <p:sp>
+        <p:nvSpPr>
+          <p:cNvPr id="5" name="Text 3"/>
+          <p:cNvSpPr/>
+          <p:nvPr/>
+        </p:nvSpPr>
+        <p:spPr>
+          <a:xfrm>
+            <a:off x="502920" y="749808"/>
+            <a:ext cx="11155680" cy="320040"/>
+          </a:xfrm>
+          <a:prstGeom prst="rect">
+            <a:avLst/>
+          </a:prstGeom>
+          <a:noFill/>
+        </p:spPr>
+        <p:txBody>
+          <a:bodyPr wrap="square" rtlCol="0" anchor="ctr"/>
+          <a:lstStyle/>
+          <a:p>
+            <a:pPr marL="0" indent="0">
+              <a:buNone/>
+            </a:pPr>
+            <a:r>
+              <a:rPr lang="en-US" sz="1400" dirty="0">
+                <a:solidFill>
+                  <a:srgbClr val="94A3B8"/>
+                </a:solidFill>
+                <a:latin typeface="微软雅黑" panose="020B0503020204020204" pitchFamily="34" charset="-122"/>
+                <a:ea typeface="微软雅黑" panose="020B0503020204020204" pitchFamily="34" charset="-122"/>
+                <a:cs typeface="微软雅黑" panose="020B0503020204020204" pitchFamily="34" charset="-120"/>
+              </a:rPr>
+              <a:t>初赛方案已齐备；本页为 8/14 交付快照</a:t>
+            </a:r>
+            <a:endParaRPr lang="en-US" sz="1400" dirty="0"/>
+          </a:p>
+        </p:txBody>
+      </p:sp>
+      <p:sp>
+        <p:nvSpPr>
+          <p:cNvPr id="6" name="Shape 4"/>
+          <p:cNvSpPr/>
+          <p:nvPr/>
+        </p:nvSpPr>
+        <p:spPr>
+          <a:xfrm>
+            <a:off x="457200" y="1371600"/>
+            <a:ext cx="2743200" cy="3017520"/>
+          </a:xfrm>
+          <a:prstGeom prst="roundRect">
+            <a:avLst>
+              <a:gd name="adj" fmla="val 3333"/>
+            </a:avLst>
+          </a:prstGeom>
+          <a:solidFill>
+            <a:srgbClr val="1F2937"/>
+          </a:solidFill>
+          <a:ln w="12700">
+            <a:solidFill>
+              <a:srgbClr val="334155"/>
+            </a:solidFill>
+            <a:prstDash val="solid"/>
+          </a:ln>
+        </p:spPr>
+      </p:sp>
+      <p:sp>
+        <p:nvSpPr>
+          <p:cNvPr id="7" name="Text 5"/>
+          <p:cNvSpPr/>
+          <p:nvPr/>
+        </p:nvSpPr>
+        <p:spPr>
+          <a:xfrm>
+            <a:off x="594360" y="1554480"/>
+            <a:ext cx="2468880" cy="411480"/>
+          </a:xfrm>
+          <a:prstGeom prst="rect">
+            <a:avLst/>
+          </a:prstGeom>
+          <a:noFill/>
+        </p:spPr>
+        <p:txBody>
+          <a:bodyPr wrap="square" rtlCol="0" anchor="ctr"/>
+          <a:lstStyle/>
+          <a:p>
+            <a:pPr marL="0" indent="0" algn="ctr">
+              <a:buNone/>
+            </a:pPr>
+            <a:r>
+              <a:rPr lang="en-US" sz="2000" b="1" dirty="0">
+                <a:solidFill>
+                  <a:srgbClr val="22D3EE"/>
+                </a:solidFill>
+                <a:latin typeface="微软雅黑" panose="020B0503020204020204" pitchFamily="34" charset="-122"/>
+                <a:ea typeface="微软雅黑" panose="020B0503020204020204" pitchFamily="34" charset="-122"/>
+                <a:cs typeface="微软雅黑" panose="020B0503020204020204" pitchFamily="34" charset="-120"/>
+              </a:rPr>
+              <a:t>核心闭环</a:t>
+            </a:r>
+            <a:endParaRPr lang="en-US" sz="2000" dirty="0"/>
+          </a:p>
+        </p:txBody>
+      </p:sp>
+      <p:sp>
+        <p:nvSpPr>
+          <p:cNvPr id="8" name="Text 6"/>
+          <p:cNvSpPr/>
+          <p:nvPr/>
+        </p:nvSpPr>
+        <p:spPr>
+          <a:xfrm>
+            <a:off x="594360" y="2011680"/>
+            <a:ext cx="2468880" cy="320040"/>
+          </a:xfrm>
+          <a:prstGeom prst="rect">
+            <a:avLst/>
+          </a:prstGeom>
+          <a:noFill/>
+        </p:spPr>
+        <p:txBody>
+          <a:bodyPr wrap="square" rtlCol="0" anchor="ctr"/>
+          <a:lstStyle/>
+          <a:p>
+            <a:pPr marL="0" indent="0" algn="ctr">
+              <a:buNone/>
+            </a:pPr>
+            <a:r>
+              <a:rPr lang="en-US" sz="1300" dirty="0">
+                <a:solidFill>
+                  <a:srgbClr val="94A3B8"/>
+                </a:solidFill>
+                <a:latin typeface="微软雅黑" panose="020B0503020204020204" pitchFamily="34" charset="-122"/>
+                <a:ea typeface="微软雅黑" panose="020B0503020204020204" pitchFamily="34" charset="-122"/>
+                <a:cs typeface="微软雅黑" panose="020B0503020204020204" pitchFamily="34" charset="-120"/>
+              </a:rPr>
+              <a:t/>
+            </a:r>
+            <a:endParaRPr lang="en-US" sz="1300" dirty="0"/>
+          </a:p>
+        </p:txBody>
+      </p:sp>
+      <p:sp>
+        <p:nvSpPr>
+          <p:cNvPr id="9" name="Text 7"/>
+          <p:cNvSpPr/>
+          <p:nvPr/>
+        </p:nvSpPr>
+        <p:spPr>
+          <a:xfrm>
+            <a:off x="640080" y="2560320"/>
+            <a:ext cx="2377440" cy="1463040"/>
+          </a:xfrm>
+          <a:prstGeom prst="rect">
+            <a:avLst/>
+          </a:prstGeom>
+          <a:noFill/>
+        </p:spPr>
+        <p:txBody>
+          <a:bodyPr wrap="square" rtlCol="0" anchor="ctr"/>
+          <a:lstStyle/>
+          <a:p>
+            <a:pPr marL="0" indent="0" algn="ctr">
+              <a:buNone/>
+            </a:pPr>
+            <a:r>
+              <a:rPr lang="en-US" sz="1400" dirty="0">
+                <a:solidFill>
+                  <a:srgbClr val="F8FAFC"/>
+                </a:solidFill>
+                <a:latin typeface="微软雅黑" panose="020B0503020204020204" pitchFamily="34" charset="-122"/>
+                <a:ea typeface="微软雅黑" panose="020B0503020204020204" pitchFamily="34" charset="-122"/>
+                <a:cs typeface="微软雅黑" panose="020B0503020204020204" pitchFamily="34" charset="-120"/>
+              </a:rPr>
+              <a:t>证据打分 · LLM 不改分</a:t>
+            </a:r>
+            <a:endParaRPr lang="en-US" sz="1400" dirty="0"/>
+          </a:p>
+          <a:p>
+            <a:pPr marL="0" indent="0" algn="ctr">
+              <a:buNone/>
+            </a:pPr>
+            <a:r>
+              <a:rPr lang="en-US" sz="1400" dirty="0">
+                <a:solidFill>
+                  <a:srgbClr val="F8FAFC"/>
+                </a:solidFill>
+                <a:latin typeface="微软雅黑" panose="020B0503020204020204" pitchFamily="34" charset="-122"/>
+                <a:ea typeface="微软雅黑" panose="020B0503020204020204" pitchFamily="34" charset="-122"/>
+                <a:cs typeface="微软雅黑" panose="020B0503020204020204" pitchFamily="34" charset="-120"/>
+              </a:rPr>
+              <a:t>练习/测评分流（D1）</a:t>
+            </a:r>
+            <a:endParaRPr lang="en-US" sz="1400" dirty="0"/>
+          </a:p>
+          <a:p>
+            <a:pPr marL="0" indent="0" algn="ctr">
+              <a:buNone/>
+            </a:pPr>
+            <a:r>
+              <a:rPr lang="en-US" sz="1400" dirty="0">
+                <a:solidFill>
+                  <a:srgbClr val="F8FAFC"/>
+                </a:solidFill>
+                <a:latin typeface="微软雅黑" panose="020B0503020204020204" pitchFamily="34" charset="-122"/>
+                <a:ea typeface="微软雅黑" panose="020B0503020204020204" pitchFamily="34" charset="-122"/>
+                <a:cs typeface="微软雅黑" panose="020B0503020204020204" pitchFamily="34" charset="-120"/>
+              </a:rPr>
+              <a:t>教师终裁 + 站内提示</a:t>
+            </a:r>
+            <a:endParaRPr lang="en-US" sz="1400" dirty="0"/>
+          </a:p>
+        </p:txBody>
+      </p:sp>
+      <p:sp>
+        <p:nvSpPr>
+          <p:cNvPr id="10" name="Shape 8"/>
+          <p:cNvSpPr/>
+          <p:nvPr/>
+        </p:nvSpPr>
+        <p:spPr>
+          <a:xfrm>
+            <a:off x="3383280" y="1371600"/>
+            <a:ext cx="2743200" cy="3017520"/>
+          </a:xfrm>
+          <a:prstGeom prst="roundRect">
+            <a:avLst>
+              <a:gd name="adj" fmla="val 3333"/>
+            </a:avLst>
+          </a:prstGeom>
+          <a:solidFill>
+            <a:srgbClr val="1F2937"/>
+          </a:solidFill>
+          <a:ln w="12700">
+            <a:solidFill>
+              <a:srgbClr val="334155"/>
+            </a:solidFill>
+            <a:prstDash val="solid"/>
+          </a:ln>
+        </p:spPr>
+      </p:sp>
+      <p:sp>
+        <p:nvSpPr>
+          <p:cNvPr id="11" name="Text 9"/>
+          <p:cNvSpPr/>
+          <p:nvPr/>
+        </p:nvSpPr>
+        <p:spPr>
+          <a:xfrm>
+            <a:off x="3520440" y="1554480"/>
+            <a:ext cx="2468880" cy="411480"/>
+          </a:xfrm>
+          <a:prstGeom prst="rect">
+            <a:avLst/>
+          </a:prstGeom>
+          <a:noFill/>
+        </p:spPr>
+        <p:txBody>
+          <a:bodyPr wrap="square" rtlCol="0" anchor="ctr"/>
+          <a:lstStyle/>
+          <a:p>
+            <a:pPr marL="0" indent="0" algn="ctr">
+              <a:buNone/>
+            </a:pPr>
+            <a:r>
+              <a:rPr lang="en-US" sz="2000" b="1" dirty="0">
+                <a:solidFill>
+                  <a:srgbClr val="22D3EE"/>
+                </a:solidFill>
+                <a:latin typeface="微软雅黑" panose="020B0503020204020204" pitchFamily="34" charset="-122"/>
+                <a:ea typeface="微软雅黑" panose="020B0503020204020204" pitchFamily="34" charset="-122"/>
+                <a:cs typeface="微软雅黑" panose="020B0503020204020204" pitchFamily="34" charset="-120"/>
+              </a:rPr>
+              <a:t>工程交付</a:t>
+            </a:r>
+            <a:endParaRPr lang="en-US" sz="2000" dirty="0"/>
+          </a:p>
+        </p:txBody>
+      </p:sp>
+      <p:sp>
+        <p:nvSpPr>
+          <p:cNvPr id="12" name="Text 10"/>
+          <p:cNvSpPr/>
+          <p:nvPr/>
+        </p:nvSpPr>
+        <p:spPr>
+          <a:xfrm>
+            <a:off x="3520440" y="2011680"/>
+            <a:ext cx="2468880" cy="320040"/>
+          </a:xfrm>
+          <a:prstGeom prst="rect">
+            <a:avLst/>
+          </a:prstGeom>
+          <a:noFill/>
+        </p:spPr>
+        <p:txBody>
+          <a:bodyPr wrap="square" rtlCol="0" anchor="ctr"/>
+          <a:lstStyle/>
+          <a:p>
+            <a:pPr marL="0" indent="0" algn="ctr">
+              <a:buNone/>
+            </a:pPr>
+            <a:r>
+              <a:rPr lang="en-US" sz="1300" dirty="0">
+                <a:solidFill>
+                  <a:srgbClr val="94A3B8"/>
+                </a:solidFill>
+                <a:latin typeface="微软雅黑" panose="020B0503020204020204" pitchFamily="34" charset="-122"/>
+                <a:ea typeface="微软雅黑" panose="020B0503020204020204" pitchFamily="34" charset="-122"/>
+                <a:cs typeface="微软雅黑" panose="020B0503020204020204" pitchFamily="34" charset="-120"/>
+              </a:rPr>
+              <a:t/>
+            </a:r>
+            <a:endParaRPr lang="en-US" sz="1300" dirty="0"/>
+          </a:p>
+        </p:txBody>
+      </p:sp>
+      <p:sp>
+        <p:nvSpPr>
+          <p:cNvPr id="13" name="Text 11"/>
+          <p:cNvSpPr/>
+          <p:nvPr/>
+        </p:nvSpPr>
+        <p:spPr>
+          <a:xfrm>
+            <a:off x="3566160" y="2560320"/>
+            <a:ext cx="2377440" cy="1463040"/>
+          </a:xfrm>
+          <a:prstGeom prst="rect">
+            <a:avLst/>
+          </a:prstGeom>
+          <a:noFill/>
+        </p:spPr>
+        <p:txBody>
+          <a:bodyPr wrap="square" rtlCol="0" anchor="ctr"/>
+          <a:lstStyle/>
+          <a:p>
+            <a:pPr marL="0" indent="0" algn="ctr">
+              <a:buNone/>
+            </a:pPr>
+            <a:r>
+              <a:rPr lang="en-US" sz="1400" dirty="0">
+                <a:solidFill>
+                  <a:srgbClr val="F8FAFC"/>
+                </a:solidFill>
+                <a:latin typeface="微软雅黑" panose="020B0503020204020204" pitchFamily="34" charset="-122"/>
+                <a:ea typeface="微软雅黑" panose="020B0503020204020204" pitchFamily="34" charset="-122"/>
+                <a:cs typeface="微软雅黑" panose="020B0503020204020204" pitchFamily="34" charset="-120"/>
+              </a:rPr>
+              <a:t>容器/Docker 沙箱</a:t>
+            </a:r>
+            <a:endParaRPr lang="en-US" sz="1400" dirty="0"/>
+          </a:p>
+          <a:p>
+            <a:pPr marL="0" indent="0" algn="ctr">
+              <a:buNone/>
+            </a:pPr>
+            <a:r>
+              <a:rPr lang="en-US" sz="1400" dirty="0">
+                <a:solidFill>
+                  <a:srgbClr val="F8FAFC"/>
+                </a:solidFill>
+                <a:latin typeface="微软雅黑" panose="020B0503020204020204" pitchFamily="34" charset="-122"/>
+                <a:ea typeface="微软雅黑" panose="020B0503020204020204" pitchFamily="34" charset="-122"/>
+                <a:cs typeface="微软雅黑" panose="020B0503020204020204" pitchFamily="34" charset="-120"/>
+              </a:rPr>
+              <a:t>7 题型 · 9 学科知识点</a:t>
+            </a:r>
+            <a:endParaRPr lang="en-US" sz="1400" dirty="0"/>
+          </a:p>
+          <a:p>
+            <a:pPr marL="0" indent="0" algn="ctr">
+              <a:buNone/>
+            </a:pPr>
+            <a:r>
+              <a:rPr lang="en-US" sz="1400" dirty="0">
+                <a:solidFill>
+                  <a:srgbClr val="F8FAFC"/>
+                </a:solidFill>
+                <a:latin typeface="微软雅黑" panose="020B0503020204020204" pitchFamily="34" charset="-122"/>
+                <a:ea typeface="微软雅黑" panose="020B0503020204020204" pitchFamily="34" charset="-122"/>
+                <a:cs typeface="微软雅黑" panose="020B0503020204020204" pitchFamily="34" charset="-120"/>
+              </a:rPr>
+              <a:t>HMAC 审计链 + PII 扫描</a:t>
+            </a:r>
+            <a:endParaRPr lang="en-US" sz="1400" dirty="0"/>
+          </a:p>
+        </p:txBody>
+      </p:sp>
+      <p:sp>
+        <p:nvSpPr>
+          <p:cNvPr id="14" name="Shape 12"/>
+          <p:cNvSpPr/>
+          <p:nvPr/>
+        </p:nvSpPr>
+        <p:spPr>
+          <a:xfrm>
+            <a:off x="6309360" y="1371600"/>
+            <a:ext cx="2743200" cy="3017520"/>
+          </a:xfrm>
+          <a:prstGeom prst="roundRect">
+            <a:avLst>
+              <a:gd name="adj" fmla="val 3333"/>
+            </a:avLst>
+          </a:prstGeom>
+          <a:solidFill>
+            <a:srgbClr val="1F2937"/>
+          </a:solidFill>
+          <a:ln w="12700">
+            <a:solidFill>
+              <a:srgbClr val="334155"/>
+            </a:solidFill>
+            <a:prstDash val="solid"/>
+          </a:ln>
+        </p:spPr>
+      </p:sp>
+      <p:sp>
+        <p:nvSpPr>
+          <p:cNvPr id="15" name="Text 13"/>
+          <p:cNvSpPr/>
+          <p:nvPr/>
+        </p:nvSpPr>
+        <p:spPr>
+          <a:xfrm>
+            <a:off x="6446520" y="1554480"/>
+            <a:ext cx="2468880" cy="411480"/>
+          </a:xfrm>
+          <a:prstGeom prst="rect">
+            <a:avLst/>
+          </a:prstGeom>
+          <a:noFill/>
+        </p:spPr>
+        <p:txBody>
+          <a:bodyPr wrap="square" rtlCol="0" anchor="ctr"/>
+          <a:lstStyle/>
+          <a:p>
+            <a:pPr marL="0" indent="0" algn="ctr">
+              <a:buNone/>
+            </a:pPr>
+            <a:r>
+              <a:rPr lang="en-US" sz="2000" b="1" dirty="0">
+                <a:solidFill>
+                  <a:srgbClr val="22D3EE"/>
+                </a:solidFill>
+                <a:latin typeface="微软雅黑" panose="020B0503020204020204" pitchFamily="34" charset="-122"/>
+                <a:ea typeface="微软雅黑" panose="020B0503020204020204" pitchFamily="34" charset="-122"/>
+                <a:cs typeface="微软雅黑" panose="020B0503020204020204" pitchFamily="34" charset="-120"/>
+              </a:rPr>
+              <a:t>决赛加码</a:t>
+            </a:r>
+            <a:endParaRPr lang="en-US" sz="2000" dirty="0"/>
+          </a:p>
+        </p:txBody>
+      </p:sp>
+      <p:sp>
+        <p:nvSpPr>
+          <p:cNvPr id="16" name="Text 14"/>
+          <p:cNvSpPr/>
+          <p:nvPr/>
+        </p:nvSpPr>
+        <p:spPr>
+          <a:xfrm>
+            <a:off x="6446520" y="2011680"/>
+            <a:ext cx="2468880" cy="320040"/>
+          </a:xfrm>
+          <a:prstGeom prst="rect">
+            <a:avLst/>
+          </a:prstGeom>
+          <a:noFill/>
+        </p:spPr>
+        <p:txBody>
+          <a:bodyPr wrap="square" rtlCol="0" anchor="ctr"/>
+          <a:lstStyle/>
+          <a:p>
+            <a:pPr marL="0" indent="0" algn="ctr">
+              <a:buNone/>
+            </a:pPr>
+            <a:r>
+              <a:rPr lang="en-US" sz="1300" dirty="0">
+                <a:solidFill>
+                  <a:srgbClr val="94A3B8"/>
+                </a:solidFill>
+                <a:latin typeface="微软雅黑" panose="020B0503020204020204" pitchFamily="34" charset="-122"/>
+                <a:ea typeface="微软雅黑" panose="020B0503020204020204" pitchFamily="34" charset="-122"/>
+                <a:cs typeface="微软雅黑" panose="020B0503020204020204" pitchFamily="34" charset="-120"/>
+              </a:rPr>
+              <a:t/>
+            </a:r>
+            <a:endParaRPr lang="en-US" sz="1300" dirty="0"/>
+          </a:p>
+        </p:txBody>
+      </p:sp>
+      <p:sp>
+        <p:nvSpPr>
+          <p:cNvPr id="17" name="Text 15"/>
+          <p:cNvSpPr/>
+          <p:nvPr/>
+        </p:nvSpPr>
+        <p:spPr>
+          <a:xfrm>
+            <a:off x="6492240" y="2560320"/>
+            <a:ext cx="2377440" cy="1463040"/>
+          </a:xfrm>
+          <a:prstGeom prst="rect">
+            <a:avLst/>
+          </a:prstGeom>
+          <a:noFill/>
+        </p:spPr>
+        <p:txBody>
+          <a:bodyPr wrap="square" rtlCol="0" anchor="ctr"/>
+          <a:lstStyle/>
+          <a:p>
+            <a:pPr marL="0" indent="0" algn="ctr">
+              <a:buNone/>
+            </a:pPr>
+            <a:r>
+              <a:rPr lang="en-US" sz="1400" dirty="0">
+                <a:solidFill>
+                  <a:srgbClr val="F8FAFC"/>
+                </a:solidFill>
+                <a:latin typeface="微软雅黑" panose="020B0503020204020204" pitchFamily="34" charset="-122"/>
+                <a:ea typeface="微软雅黑" panose="020B0503020204020204" pitchFamily="34" charset="-122"/>
+                <a:cs typeface="微软雅黑" panose="020B0503020204020204" pitchFamily="34" charset="-120"/>
+              </a:rPr>
+              <a:t>成套服务端交卷</a:t>
+            </a:r>
+            <a:endParaRPr lang="en-US" sz="1400" dirty="0"/>
+          </a:p>
+          <a:p>
+            <a:pPr marL="0" indent="0" algn="ctr">
+              <a:buNone/>
+            </a:pPr>
+            <a:r>
+              <a:rPr lang="en-US" sz="1400" dirty="0">
+                <a:solidFill>
+                  <a:srgbClr val="F8FAFC"/>
+                </a:solidFill>
+                <a:latin typeface="微软雅黑" panose="020B0503020204020204" pitchFamily="34" charset="-122"/>
+                <a:ea typeface="微软雅黑" panose="020B0503020204020204" pitchFamily="34" charset="-122"/>
+                <a:cs typeface="微软雅黑" panose="020B0503020204020204" pitchFamily="34" charset="-120"/>
+              </a:rPr>
+              <a:t>家长端 + 子女绑定</a:t>
+            </a:r>
+            <a:endParaRPr lang="en-US" sz="1400" dirty="0"/>
+          </a:p>
+          <a:p>
+            <a:pPr marL="0" indent="0" algn="ctr">
+              <a:buNone/>
+            </a:pPr>
+            <a:r>
+              <a:rPr lang="en-US" sz="1400" dirty="0">
+                <a:solidFill>
+                  <a:srgbClr val="F8FAFC"/>
+                </a:solidFill>
+                <a:latin typeface="微软雅黑" panose="020B0503020204020204" pitchFamily="34" charset="-122"/>
+                <a:ea typeface="微软雅黑" panose="020B0503020204020204" pitchFamily="34" charset="-122"/>
+                <a:cs typeface="微软雅黑" panose="020B0503020204020204" pitchFamily="34" charset="-120"/>
+              </a:rPr>
+              <a:t>Excel 兼容 CSV 导出</a:t>
+            </a:r>
+            <a:endParaRPr lang="en-US" sz="1400" dirty="0"/>
+          </a:p>
+        </p:txBody>
+      </p:sp>
+      <p:sp>
+        <p:nvSpPr>
+          <p:cNvPr id="18" name="Shape 16"/>
+          <p:cNvSpPr/>
+          <p:nvPr/>
+        </p:nvSpPr>
+        <p:spPr>
+          <a:xfrm>
+            <a:off x="9235440" y="1371600"/>
+            <a:ext cx="2743200" cy="3017520"/>
+          </a:xfrm>
+          <a:prstGeom prst="roundRect">
+            <a:avLst>
+              <a:gd name="adj" fmla="val 3333"/>
+            </a:avLst>
+          </a:prstGeom>
+          <a:solidFill>
+            <a:srgbClr val="1F2937"/>
+          </a:solidFill>
+          <a:ln w="12700">
+            <a:solidFill>
+              <a:srgbClr val="334155"/>
+            </a:solidFill>
+            <a:prstDash val="solid"/>
+          </a:ln>
+        </p:spPr>
+      </p:sp>
+      <p:sp>
+        <p:nvSpPr>
+          <p:cNvPr id="19" name="Text 17"/>
+          <p:cNvSpPr/>
+          <p:nvPr/>
+        </p:nvSpPr>
+        <p:spPr>
+          <a:xfrm>
+            <a:off x="9372600" y="1554480"/>
+            <a:ext cx="2468880" cy="411480"/>
+          </a:xfrm>
+          <a:prstGeom prst="rect">
+            <a:avLst/>
+          </a:prstGeom>
+          <a:noFill/>
+        </p:spPr>
+        <p:txBody>
+          <a:bodyPr wrap="square" rtlCol="0" anchor="ctr"/>
+          <a:lstStyle/>
+          <a:p>
+            <a:pPr marL="0" indent="0" algn="ctr">
+              <a:buNone/>
+            </a:pPr>
+            <a:r>
+              <a:rPr lang="en-US" sz="2000" b="1" dirty="0">
+                <a:solidFill>
+                  <a:srgbClr val="22D3EE"/>
+                </a:solidFill>
+                <a:latin typeface="微软雅黑" panose="020B0503020204020204" pitchFamily="34" charset="-122"/>
+                <a:ea typeface="微软雅黑" panose="020B0503020204020204" pitchFamily="34" charset="-122"/>
+                <a:cs typeface="微软雅黑" panose="020B0503020204020204" pitchFamily="34" charset="-120"/>
+              </a:rPr>
+              <a:t>诚实边界</a:t>
+            </a:r>
+            <a:endParaRPr lang="en-US" sz="2000" dirty="0"/>
+          </a:p>
+        </p:txBody>
+      </p:sp>
+      <p:sp>
+        <p:nvSpPr>
+          <p:cNvPr id="20" name="Text 18"/>
+          <p:cNvSpPr/>
+          <p:nvPr/>
+        </p:nvSpPr>
+        <p:spPr>
+          <a:xfrm>
+            <a:off x="9372600" y="2011680"/>
+            <a:ext cx="2468880" cy="320040"/>
+          </a:xfrm>
+          <a:prstGeom prst="rect">
+            <a:avLst/>
+          </a:prstGeom>
+          <a:noFill/>
+        </p:spPr>
+        <p:txBody>
+          <a:bodyPr wrap="square" rtlCol="0" anchor="ctr"/>
+          <a:lstStyle/>
+          <a:p>
+            <a:pPr marL="0" indent="0" algn="ctr">
+              <a:buNone/>
+            </a:pPr>
+            <a:r>
+              <a:rPr lang="en-US" sz="1300" dirty="0">
+                <a:solidFill>
+                  <a:srgbClr val="94A3B8"/>
+                </a:solidFill>
+                <a:latin typeface="微软雅黑" panose="020B0503020204020204" pitchFamily="34" charset="-122"/>
+                <a:ea typeface="微软雅黑" panose="020B0503020204020204" pitchFamily="34" charset="-122"/>
+                <a:cs typeface="微软雅黑" panose="020B0503020204020204" pitchFamily="34" charset="-120"/>
+              </a:rPr>
+              <a:t/>
+            </a:r>
+            <a:endParaRPr lang="en-US" sz="1300" dirty="0"/>
+          </a:p>
+        </p:txBody>
+      </p:sp>
+      <p:sp>
+        <p:nvSpPr>
+          <p:cNvPr id="21" name="Text 19"/>
+          <p:cNvSpPr/>
+          <p:nvPr/>
+        </p:nvSpPr>
+        <p:spPr>
+          <a:xfrm>
+            <a:off x="9418320" y="2560320"/>
+            <a:ext cx="2377440" cy="1463040"/>
+          </a:xfrm>
+          <a:prstGeom prst="rect">
+            <a:avLst/>
+          </a:prstGeom>
+          <a:noFill/>
+        </p:spPr>
+        <p:txBody>
+          <a:bodyPr wrap="square" rtlCol="0" anchor="ctr"/>
+          <a:lstStyle/>
+          <a:p>
+            <a:pPr marL="0" indent="0" algn="ctr">
+              <a:buNone/>
+            </a:pPr>
+            <a:r>
+              <a:rPr lang="en-US" sz="1400" dirty="0">
+                <a:solidFill>
+                  <a:srgbClr val="F8FAFC"/>
+                </a:solidFill>
+                <a:latin typeface="微软雅黑" panose="020B0503020204020204" pitchFamily="34" charset="-122"/>
+                <a:ea typeface="微软雅黑" panose="020B0503020204020204" pitchFamily="34" charset="-122"/>
+                <a:cs typeface="微软雅黑" panose="020B0503020204020204" pitchFamily="34" charset="-120"/>
+              </a:rPr>
+              <a:t>Demo 假多租户</a:t>
+            </a:r>
+            <a:endParaRPr lang="en-US" sz="1400" dirty="0"/>
+          </a:p>
+          <a:p>
+            <a:pPr marL="0" indent="0" algn="ctr">
+              <a:buNone/>
+            </a:pPr>
+            <a:r>
+              <a:rPr lang="en-US" sz="1400" dirty="0">
+                <a:solidFill>
+                  <a:srgbClr val="F8FAFC"/>
+                </a:solidFill>
+                <a:latin typeface="微软雅黑" panose="020B0503020204020204" pitchFamily="34" charset="-122"/>
+                <a:ea typeface="微软雅黑" panose="020B0503020204020204" pitchFamily="34" charset="-122"/>
+                <a:cs typeface="微软雅黑" panose="020B0503020204020204" pitchFamily="34" charset="-120"/>
+              </a:rPr>
+              <a:t>短信/推送未做</a:t>
+            </a:r>
+            <a:endParaRPr lang="en-US" sz="1400" dirty="0"/>
+          </a:p>
+          <a:p>
+            <a:pPr marL="0" indent="0" algn="ctr">
+              <a:buNone/>
+            </a:pPr>
+            <a:r>
+              <a:rPr lang="en-US" sz="1400" dirty="0">
+                <a:solidFill>
+                  <a:srgbClr val="F8FAFC"/>
+                </a:solidFill>
+                <a:latin typeface="微软雅黑" panose="020B0503020204020204" pitchFamily="34" charset="-122"/>
+                <a:ea typeface="微软雅黑" panose="020B0503020204020204" pitchFamily="34" charset="-122"/>
+                <a:cs typeface="微软雅黑" panose="020B0503020204020204" pitchFamily="34" charset="-120"/>
+              </a:rPr>
+              <a:t>LMS/SIS 对接待做</a:t>
+            </a:r>
+            <a:endParaRPr lang="en-US" sz="1400" dirty="0"/>
+          </a:p>
+        </p:txBody>
+      </p:sp>
+      <p:sp>
+        <p:nvSpPr>
+          <p:cNvPr id="22" name="Text 20"/>
+          <p:cNvSpPr/>
+          <p:nvPr/>
+        </p:nvSpPr>
+        <p:spPr>
+          <a:xfrm>
+            <a:off x="502920" y="4709160"/>
+            <a:ext cx="11155680" cy="411480"/>
+          </a:xfrm>
+          <a:prstGeom prst="rect">
+            <a:avLst/>
+          </a:prstGeom>
+          <a:noFill/>
+        </p:spPr>
+        <p:txBody>
+          <a:bodyPr wrap="square" rtlCol="0" anchor="ctr"/>
+          <a:lstStyle/>
+          <a:p>
+            <a:pPr marL="0" indent="0">
+              <a:buNone/>
+            </a:pPr>
+            <a:r>
+              <a:rPr lang="en-US" sz="1600" b="1" dirty="0">
+                <a:solidFill>
+                  <a:srgbClr val="F8FAFC"/>
+                </a:solidFill>
+                <a:latin typeface="微软雅黑" panose="020B0503020204020204" pitchFamily="34" charset="-122"/>
+                <a:ea typeface="微软雅黑" panose="020B0503020204020204" pitchFamily="34" charset="-122"/>
+                <a:cs typeface="微软雅黑" panose="020B0503020204020204" pitchFamily="34" charset="-120"/>
+              </a:rPr>
+              <a:t>一句话：用可验证证据驱动编程实训，而不是又一个会聊天的助教。</a:t>
+            </a:r>
+            <a:endParaRPr lang="en-US" sz="1600" dirty="0"/>
+          </a:p>
+        </p:txBody>
+      </p:sp>
+      <p:sp>
+        <p:nvSpPr>
+          <p:cNvPr id="23" name="Text 21"/>
+          <p:cNvSpPr/>
+          <p:nvPr/>
+        </p:nvSpPr>
+        <p:spPr>
+          <a:xfrm>
+            <a:off x="502920" y="5166360"/>
+            <a:ext cx="11155680" cy="320040"/>
+          </a:xfrm>
+          <a:prstGeom prst="rect">
+            <a:avLst/>
+          </a:prstGeom>
+          <a:noFill/>
+        </p:spPr>
+        <p:txBody>
+          <a:bodyPr wrap="square" rtlCol="0" anchor="ctr"/>
+          <a:lstStyle/>
+          <a:p>
+            <a:pPr marL="0" indent="0">
+              <a:buNone/>
+            </a:pPr>
+            <a:r>
+              <a:rPr lang="en-US" sz="1300" dirty="0">
+                <a:solidFill>
+                  <a:srgbClr val="94A3B8"/>
+                </a:solidFill>
+                <a:latin typeface="Consolas" panose="020B0609020204030204" pitchFamily="34" charset="0"/>
+                <a:ea typeface="Consolas" panose="020B0609020204030204" pitchFamily="34" charset="-122"/>
+                <a:cs typeface="Consolas" panose="020B0609020204030204" pitchFamily="34" charset="-120"/>
+              </a:rPr>
+              <a:t>本地演示：cd D:\code_space\evidence-loop  →  npm run dev  →  http://localhost:5280</a:t>
+            </a:r>
+            <a:endParaRPr lang="en-US" sz="1300" dirty="0"/>
+          </a:p>
+        </p:txBody>
+      </p:sp>
+      <p:sp>
+        <p:nvSpPr>
+          <p:cNvPr id="24" name="Text 22"/>
+          <p:cNvSpPr/>
+          <p:nvPr/>
+        </p:nvSpPr>
+        <p:spPr>
+          <a:xfrm>
+            <a:off x="457200" y="6492240"/>
+            <a:ext cx="8686800" cy="256032"/>
+          </a:xfrm>
+          <a:prstGeom prst="rect">
+            <a:avLst/>
+          </a:prstGeom>
+          <a:noFill/>
+        </p:spPr>
+        <p:txBody>
+          <a:bodyPr wrap="square" rtlCol="0" anchor="ctr"/>
+          <a:lstStyle/>
+          <a:p>
+            <a:pPr marL="0" indent="0">
+              <a:buNone/>
+            </a:pPr>
+            <a:r>
+              <a:rPr lang="en-US" sz="1100" dirty="0">
+                <a:solidFill>
+                  <a:srgbClr val="94A3B8"/>
+                </a:solidFill>
+                <a:latin typeface="微软雅黑" panose="020B0503020204020204" pitchFamily="34" charset="-122"/>
+                <a:ea typeface="微软雅黑" panose="020B0503020204020204" pitchFamily="34" charset="-122"/>
+                <a:cs typeface="微软雅黑" panose="020B0503020204020204" pitchFamily="34" charset="-120"/>
+              </a:rPr>
+              <a:t>EvidenceRing · GOAI Boundless Agents · AI+教育</a:t>
+            </a:r>
+            <a:endParaRPr lang="en-US" sz="1100" dirty="0"/>
+          </a:p>
+        </p:txBody>
+      </p:sp>
+      <p:sp>
+        <p:nvSpPr>
+          <p:cNvPr id="25" name="Text 23"/>
+          <p:cNvSpPr/>
+          <p:nvPr/>
+        </p:nvSpPr>
+        <p:spPr>
+          <a:xfrm>
+            <a:off x="10332720" y="6492240"/>
+            <a:ext cx="1371600" cy="256032"/>
+          </a:xfrm>
+          <a:prstGeom prst="rect">
+            <a:avLst/>
+          </a:prstGeom>
+          <a:noFill/>
+        </p:spPr>
+        <p:txBody>
+          <a:bodyPr wrap="square" rtlCol="0" anchor="ctr"/>
+          <a:lstStyle/>
+          <a:p>
+            <a:pPr marL="0" indent="0" algn="r">
+              <a:buNone/>
+            </a:pPr>
+            <a:r>
+              <a:rPr lang="en-US" sz="1100" dirty="0">
+                <a:solidFill>
+                  <a:srgbClr val="94A3B8"/>
+                </a:solidFill>
+                <a:latin typeface="微软雅黑" panose="020B0503020204020204" pitchFamily="34" charset="-122"/>
+                <a:ea typeface="微软雅黑" panose="020B0503020204020204" pitchFamily="34" charset="-122"/>
+                <a:cs typeface="微软雅黑" panose="020B0503020204020204" pitchFamily="34" charset="-120"/>
+              </a:rPr>
+              <a:t>10 / 11</a:t>
             </a:r>
             <a:endParaRPr lang="en-US" sz="1100" dirty="0"/>
           </a:p>
@@ -4011,7 +5015,7 @@
                 <a:ea typeface="微软雅黑" panose="020B0503020204020204" pitchFamily="34" charset="-122"/>
                 <a:cs typeface="微软雅黑" panose="020B0503020204020204" pitchFamily="34" charset="-120"/>
               </a:rPr>
-              <a:t>EvidenceLoop · GOAI Boundless Agents · AI+教育</a:t>
+              <a:t>EvidenceRing · GOAI Boundless Agents · AI+教育</a:t>
             </a:r>
             <a:endParaRPr lang="en-US" sz="1100" dirty="0"/>
           </a:p>
@@ -4049,7 +5053,7 @@
                 <a:ea typeface="微软雅黑" panose="020B0503020204020204" pitchFamily="34" charset="-122"/>
                 <a:cs typeface="微软雅黑" panose="020B0503020204020204" pitchFamily="34" charset="-120"/>
               </a:rPr>
-              <a:t>2 / 10</a:t>
+              <a:t>2 / 11</a:t>
             </a:r>
             <a:endParaRPr lang="en-US" sz="1100" dirty="0"/>
           </a:p>
@@ -4711,7 +5715,7 @@
                 <a:ea typeface="微软雅黑" panose="020B0503020204020204" pitchFamily="34" charset="-122"/>
                 <a:cs typeface="微软雅黑" panose="020B0503020204020204" pitchFamily="34" charset="-120"/>
               </a:rPr>
-              <a:t>EvidenceLoop · GOAI Boundless Agents · AI+教育</a:t>
+              <a:t>EvidenceRing · GOAI Boundless Agents · AI+教育</a:t>
             </a:r>
             <a:endParaRPr lang="en-US" sz="1100" dirty="0"/>
           </a:p>
@@ -4749,7 +5753,7 @@
                 <a:ea typeface="微软雅黑" panose="020B0503020204020204" pitchFamily="34" charset="-122"/>
                 <a:cs typeface="微软雅黑" panose="020B0503020204020204" pitchFamily="34" charset="-120"/>
               </a:rPr>
-              <a:t>3 / 10</a:t>
+              <a:t>3 / 11</a:t>
             </a:r>
             <a:endParaRPr lang="en-US" sz="1100" dirty="0"/>
           </a:p>
@@ -5442,7 +6446,7 @@
                 <a:ea typeface="微软雅黑" panose="020B0503020204020204" pitchFamily="34" charset="-122"/>
                 <a:cs typeface="微软雅黑" panose="020B0503020204020204" pitchFamily="34" charset="-120"/>
               </a:rPr>
-              <a:t>EvidenceLoop · GOAI Boundless Agents · AI+教育</a:t>
+              <a:t>EvidenceRing · GOAI Boundless Agents · AI+教育</a:t>
             </a:r>
             <a:endParaRPr lang="en-US" sz="1100" dirty="0"/>
           </a:p>
@@ -5480,7 +6484,7 @@
                 <a:ea typeface="微软雅黑" panose="020B0503020204020204" pitchFamily="34" charset="-122"/>
                 <a:cs typeface="微软雅黑" panose="020B0503020204020204" pitchFamily="34" charset="-120"/>
               </a:rPr>
-              <a:t>4 / 10</a:t>
+              <a:t>4 / 11</a:t>
             </a:r>
             <a:endParaRPr lang="en-US" sz="1100" dirty="0"/>
           </a:p>
@@ -6651,7 +7655,7 @@
                 <a:ea typeface="微软雅黑" panose="020B0503020204020204" pitchFamily="34" charset="-122"/>
                 <a:cs typeface="微软雅黑" panose="020B0503020204020204" pitchFamily="34" charset="-120"/>
               </a:rPr>
-              <a:t>EvidenceLoop · GOAI Boundless Agents · AI+教育</a:t>
+              <a:t>EvidenceRing · GOAI Boundless Agents · AI+教育</a:t>
             </a:r>
             <a:endParaRPr lang="en-US" sz="1100" dirty="0"/>
           </a:p>
@@ -6689,7 +7693,7 @@
                 <a:ea typeface="微软雅黑" panose="020B0503020204020204" pitchFamily="34" charset="-122"/>
                 <a:cs typeface="微软雅黑" panose="020B0503020204020204" pitchFamily="34" charset="-120"/>
               </a:rPr>
-              <a:t>5 / 10</a:t>
+              <a:t>5 / 11</a:t>
             </a:r>
             <a:endParaRPr lang="en-US" sz="1100" dirty="0"/>
           </a:p>
@@ -7349,7 +8353,7 @@
                 <a:ea typeface="微软雅黑" panose="020B0503020204020204" pitchFamily="34" charset="-122"/>
                 <a:cs typeface="微软雅黑" panose="020B0503020204020204" pitchFamily="34" charset="-120"/>
               </a:rPr>
-              <a:t>EvidenceLoop · GOAI Boundless Agents · AI+教育</a:t>
+              <a:t>EvidenceRing · GOAI Boundless Agents · AI+教育</a:t>
             </a:r>
             <a:endParaRPr lang="en-US" sz="1100" dirty="0"/>
           </a:p>
@@ -7387,7 +8391,7 @@
                 <a:ea typeface="微软雅黑" panose="020B0503020204020204" pitchFamily="34" charset="-122"/>
                 <a:cs typeface="微软雅黑" panose="020B0503020204020204" pitchFamily="34" charset="-120"/>
               </a:rPr>
-              <a:t>6 / 10</a:t>
+              <a:t>6 / 11</a:t>
             </a:r>
             <a:endParaRPr lang="en-US" sz="1100" dirty="0"/>
           </a:p>
@@ -8156,7 +9160,7 @@
                 <a:ea typeface="微软雅黑" panose="020B0503020204020204" pitchFamily="34" charset="-122"/>
                 <a:cs typeface="微软雅黑" panose="020B0503020204020204" pitchFamily="34" charset="-120"/>
               </a:rPr>
-              <a:t>EvidenceLoop · GOAI Boundless Agents · AI+教育</a:t>
+              <a:t>EvidenceRing · GOAI Boundless Agents · AI+教育</a:t>
             </a:r>
             <a:endParaRPr lang="en-US" sz="1100" dirty="0"/>
           </a:p>
@@ -8194,7 +9198,7 @@
                 <a:ea typeface="微软雅黑" panose="020B0503020204020204" pitchFamily="34" charset="-122"/>
                 <a:cs typeface="微软雅黑" panose="020B0503020204020204" pitchFamily="34" charset="-120"/>
               </a:rPr>
-              <a:t>7 / 10</a:t>
+              <a:t>7 / 11</a:t>
             </a:r>
             <a:endParaRPr lang="en-US" sz="1100" dirty="0"/>
           </a:p>
@@ -8795,7 +9799,7 @@
                 <a:ea typeface="微软雅黑" panose="020B0503020204020204" pitchFamily="34" charset="-122"/>
                 <a:cs typeface="微软雅黑" panose="020B0503020204020204" pitchFamily="34" charset="-120"/>
               </a:rPr>
-              <a:t>EvidenceLoop · GOAI Boundless Agents · AI+教育</a:t>
+              <a:t>EvidenceRing · GOAI Boundless Agents · AI+教育</a:t>
             </a:r>
             <a:endParaRPr lang="en-US" sz="1100" dirty="0"/>
           </a:p>
@@ -8833,7 +9837,7 @@
                 <a:ea typeface="微软雅黑" panose="020B0503020204020204" pitchFamily="34" charset="-122"/>
                 <a:cs typeface="微软雅黑" panose="020B0503020204020204" pitchFamily="34" charset="-120"/>
               </a:rPr>
-              <a:t>8 / 10</a:t>
+              <a:t>8 / 11</a:t>
             </a:r>
             <a:endParaRPr lang="en-US" sz="1100" dirty="0"/>
           </a:p>
@@ -9236,7 +10240,7 @@
                 <a:ea typeface="微软雅黑" panose="020B0503020204020204" pitchFamily="34" charset="-122"/>
                 <a:cs typeface="微软雅黑" panose="020B0503020204020204" pitchFamily="34" charset="-120"/>
               </a:rPr>
-              <a:t>EvidenceLoop</a:t>
+              <a:t>EvidenceRing</a:t>
             </a:r>
             <a:endParaRPr lang="en-US" sz="1300" dirty="0"/>
           </a:p>
@@ -10572,7 +11576,7 @@
                 <a:ea typeface="微软雅黑" panose="020B0503020204020204" pitchFamily="34" charset="-122"/>
                 <a:cs typeface="微软雅黑" panose="020B0503020204020204" pitchFamily="34" charset="-120"/>
               </a:rPr>
-              <a:t>EvidenceLoop · GOAI Boundless Agents · AI+教育</a:t>
+              <a:t>EvidenceRing · GOAI Boundless Agents · AI+教育</a:t>
             </a:r>
             <a:endParaRPr lang="en-US" sz="1100" dirty="0"/>
           </a:p>
@@ -10610,7 +11614,7 @@
                 <a:ea typeface="微软雅黑" panose="020B0503020204020204" pitchFamily="34" charset="-122"/>
                 <a:cs typeface="微软雅黑" panose="020B0503020204020204" pitchFamily="34" charset="-120"/>
               </a:rPr>
-              <a:t>9 / 10</a:t>
+              <a:t>9 / 11</a:t>
             </a:r>
             <a:endParaRPr lang="en-US" sz="1100" dirty="0"/>
           </a:p>

</xml_diff>